<commit_message>
guide pas-a-pas detaille : PDF, PowerPoint et Markdown mis a jour
</commit_message>
<xml_diff>
--- a/guide_utilisation.pptx
+++ b/guide_utilisation.pptx
@@ -11,6 +11,7 @@
     <p:sldId id="259" r:id="rId10"/>
     <p:sldId id="260" r:id="rId11"/>
     <p:sldId id="261" r:id="rId12"/>
+    <p:sldId id="262" r:id="rId13"/>
   </p:sldIdLst>
   <p:sldSz cx="12191695" cy="6858000" type="screen4x3"/>
   <p:notesSz cx="6858000" cy="9144000"/>
@@ -3109,8 +3110,8 @@
         </p:nvSpPr>
         <p:spPr>
           <a:xfrm>
-            <a:off x="914400" y="2011680"/>
-            <a:ext cx="10360152" cy="2743200"/>
+            <a:off x="914400" y="1828800"/>
+            <a:ext cx="10360152" cy="3200400"/>
           </a:xfrm>
           <a:prstGeom prst="rect">
             <a:avLst/>
@@ -3145,20 +3146,7 @@
               </a:defRPr>
             </a:pPr>
             <a:r>
-              <a:t>Guide d'Utilisation Numérique Complet</a:t>
-            </a:r>
-          </a:p>
-          <a:p>
-            <a:pPr>
-              <a:defRPr sz="1800">
-                <a:solidFill>
-                  <a:srgbClr val="C8DCFF"/>
-                </a:solidFill>
-                <a:latin typeface="Arial"/>
-              </a:defRPr>
-            </a:pPr>
-            <a:r>
-              <a:t>Gestion Scolaire • Emploi du Temps • Notes &amp; Facturation</a:t>
+              <a:t>Guide Procédural &amp; Tutoriels Étape par Étape</a:t>
             </a:r>
           </a:p>
         </p:txBody>
@@ -3212,7 +3200,7 @@
           <a:lstStyle/>
           <a:p>
             <a:pPr>
-              <a:defRPr sz="2800" b="1">
+              <a:defRPr sz="2400" b="1">
                 <a:solidFill>
                   <a:srgbClr val="0B4998"/>
                 </a:solidFill>
@@ -3220,7 +3208,7 @@
               </a:defRPr>
             </a:pPr>
             <a:r>
-              <a:t>1. Rôles &amp; Gestion des Accès (RBAC)</a:t>
+              <a:t>Tutoriel 1 : Créer un utilisateur &amp; attribuer des droits</a:t>
             </a:r>
           </a:p>
         </p:txBody>
@@ -3233,8 +3221,8 @@
         </p:nvSpPr>
         <p:spPr>
           <a:xfrm>
-            <a:off x="457200" y="1371600"/>
-            <a:ext cx="11274552" cy="4572000"/>
+            <a:off x="457200" y="1097280"/>
+            <a:ext cx="11274552" cy="5303520"/>
           </a:xfrm>
           <a:prstGeom prst="rect">
             <a:avLst/>
@@ -3250,77 +3238,96 @@
           <a:p>
             <a:pPr/>
             <a:r>
-              <a:rPr b="1" sz="1800">
-                <a:solidFill>
-                  <a:srgbClr val="1E293B"/>
-                </a:solidFill>
-              </a:rPr>
-              <a:t>• Directeur / Super Admin : </a:t>
-            </a:r>
-            <a:r>
-              <a:rPr sz="1600">
-                <a:solidFill>
-                  <a:srgbClr val="1E293B"/>
-                </a:solidFill>
-              </a:rPr>
-              <a:t>Accès total à tous les onglets, modification des droits, déverrouillage des notes figées et validation finale des Procès-Verbaux (PV).</a:t>
+              <a:rPr b="1" sz="1500">
+                <a:solidFill>
+                  <a:srgbClr val="1E293B"/>
+                </a:solidFill>
+              </a:rPr>
+              <a:t>1. Ouvrir l'onglet : </a:t>
+            </a:r>
+            <a:r>
+              <a:rPr sz="1400">
+                <a:solidFill>
+                  <a:srgbClr val="1E293B"/>
+                </a:solidFill>
+              </a:rPr>
+              <a:t>Sélectionnez l'onglet 'Administration' dans le menu principal.</a:t>
             </a:r>
           </a:p>
           <a:p>
             <a:pPr/>
             <a:r>
-              <a:rPr b="1" sz="1800">
-                <a:solidFill>
-                  <a:srgbClr val="1E293B"/>
-                </a:solidFill>
-              </a:rPr>
-              <a:t>• Correspondant Fichier (Informaticien) : </a:t>
-            </a:r>
-            <a:r>
-              <a:rPr sz="1600">
-                <a:solidFill>
-                  <a:srgbClr val="1E293B"/>
-                </a:solidFill>
-              </a:rPr>
-              <a:t>Gestion technique des bases de données, inscriptions, configurations d'EDT et correctifs de notes.</a:t>
+              <a:rPr b="1" sz="1500">
+                <a:solidFill>
+                  <a:srgbClr val="1E293B"/>
+                </a:solidFill>
+              </a:rPr>
+              <a:t>2. Remplir le formulaire : </a:t>
+            </a:r>
+            <a:r>
+              <a:rPr sz="1400">
+                <a:solidFill>
+                  <a:srgbClr val="1E293B"/>
+                </a:solidFill>
+              </a:rPr>
+              <a:t>Allez à 'Créer un nouveau compte utilisateur', entrez le Nom complet, l'Email/Identifiant, et le Mot de passe.</a:t>
             </a:r>
           </a:p>
           <a:p>
             <a:pPr/>
             <a:r>
-              <a:rPr b="1" sz="1800">
-                <a:solidFill>
-                  <a:srgbClr val="1E293B"/>
-                </a:solidFill>
-              </a:rPr>
-              <a:t>• Professeurs : </a:t>
-            </a:r>
-            <a:r>
-              <a:rPr sz="1600">
-                <a:solidFill>
-                  <a:srgbClr val="1E293B"/>
-                </a:solidFill>
-              </a:rPr>
-              <a:t>Accès limité à l'emploi du temps personnel et saisie des notes uniquement sur autorisation expresse.</a:t>
+              <a:rPr b="1" sz="1500">
+                <a:solidFill>
+                  <a:srgbClr val="1E293B"/>
+                </a:solidFill>
+              </a:rPr>
+              <a:t>3. Sélectionner le rôle : </a:t>
+            </a:r>
+            <a:r>
+              <a:rPr sz="1400">
+                <a:solidFill>
+                  <a:srgbClr val="1E293B"/>
+                </a:solidFill>
+              </a:rPr>
+              <a:t>Choisissez le rôle approprié dans la liste déroulante (Super Admin, Directeur, Informaticien, Professeur).</a:t>
             </a:r>
           </a:p>
           <a:p>
             <a:pPr/>
             <a:r>
-              <a:rPr b="1" sz="1800">
-                <a:solidFill>
-                  <a:srgbClr val="1E293B"/>
-                </a:solidFill>
-              </a:rPr>
-              <a:t>• Attribution des droits : </a:t>
-            </a:r>
-            <a:r>
-              <a:rPr sz="1600">
-                <a:solidFill>
-                  <a:srgbClr val="1E293B"/>
-                </a:solidFill>
-              </a:rPr>
-              <a:t>Le Directeur attribue la permission 'Saisie des Moyennes' dynamiquement via l'onglet Administration.</a:t>
+              <a:rPr b="1" sz="1500">
+                <a:solidFill>
+                  <a:srgbClr val="1E293B"/>
+                </a:solidFill>
+              </a:rPr>
+              <a:t>4. Enregistrer : </a:t>
+            </a:r>
+            <a:r>
+              <a:rPr sz="1400">
+                <a:solidFill>
+                  <a:srgbClr val="1E293B"/>
+                </a:solidFill>
+              </a:rPr>
+              <a:t>Cliquez sur le bouton orange 'Créer le compte utilisateur'.</a:t>
+            </a:r>
+          </a:p>
+          <a:p>
+            <a:pPr/>
+            <a:r>
+              <a:rPr b="1" sz="1500">
+                <a:solidFill>
+                  <a:srgbClr val="1E293B"/>
+                </a:solidFill>
+              </a:rPr>
+              <a:t>5. Assigner la Saisie des Moyennes : </a:t>
+            </a:r>
+            <a:r>
+              <a:rPr sz="1400">
+                <a:solidFill>
+                  <a:srgbClr val="1E293B"/>
+                </a:solidFill>
+              </a:rPr>
+              <a:t>Dans la liste des comptes ci-dessous, repérez l'utilisateur et cochez la case 'Saisie des Moyennes'.</a:t>
             </a:r>
           </a:p>
         </p:txBody>
@@ -3374,7 +3381,7 @@
           <a:lstStyle/>
           <a:p>
             <a:pPr>
-              <a:defRPr sz="2800" b="1">
+              <a:defRPr sz="2400" b="1">
                 <a:solidFill>
                   <a:srgbClr val="0B4998"/>
                 </a:solidFill>
@@ -3382,7 +3389,7 @@
               </a:defRPr>
             </a:pPr>
             <a:r>
-              <a:t>2. Saisie des Moyennes &amp; Verrouillage</a:t>
+              <a:t>Tutoriel 2 : Planifier un cours sur l'Emploi du Temps</a:t>
             </a:r>
           </a:p>
         </p:txBody>
@@ -3395,8 +3402,8 @@
         </p:nvSpPr>
         <p:spPr>
           <a:xfrm>
-            <a:off x="457200" y="1371600"/>
-            <a:ext cx="11274552" cy="4572000"/>
+            <a:off x="457200" y="1097280"/>
+            <a:ext cx="11274552" cy="5303520"/>
           </a:xfrm>
           <a:prstGeom prst="rect">
             <a:avLst/>
@@ -3412,77 +3419,96 @@
           <a:p>
             <a:pPr/>
             <a:r>
-              <a:rPr b="1" sz="1800">
-                <a:solidFill>
-                  <a:srgbClr val="1E293B"/>
-                </a:solidFill>
-              </a:rPr>
-              <a:t>• Saisie par le Professeur : </a:t>
-            </a:r>
-            <a:r>
-              <a:rPr sz="1600">
-                <a:solidFill>
-                  <a:srgbClr val="1E293B"/>
-                </a:solidFill>
-              </a:rPr>
-              <a:t>Le professeur remplit la grille de notes pour sa classe/matière autorisée.</a:t>
+              <a:rPr b="1" sz="1500">
+                <a:solidFill>
+                  <a:srgbClr val="1E293B"/>
+                </a:solidFill>
+              </a:rPr>
+              <a:t>1. Accéder au module : </a:t>
+            </a:r>
+            <a:r>
+              <a:rPr sz="1400">
+                <a:solidFill>
+                  <a:srgbClr val="1E293B"/>
+                </a:solidFill>
+              </a:rPr>
+              <a:t>Allez sur l'onglet 'EDT - Planification'.</a:t>
             </a:r>
           </a:p>
           <a:p>
             <a:pPr/>
             <a:r>
-              <a:rPr b="1" sz="1800">
-                <a:solidFill>
-                  <a:srgbClr val="1E293B"/>
-                </a:solidFill>
-              </a:rPr>
-              <a:t>• Action 'Valider &amp; Figer' : </a:t>
-            </a:r>
-            <a:r>
-              <a:rPr sz="1600">
-                <a:solidFill>
-                  <a:srgbClr val="1E293B"/>
-                </a:solidFill>
-              </a:rPr>
-              <a:t>Une fois validées, les notes passent au statut verrouillé (🔒). L'enseignant ne peut plus les modifier.</a:t>
+              <a:rPr b="1" sz="1500">
+                <a:solidFill>
+                  <a:srgbClr val="1E293B"/>
+                </a:solidFill>
+              </a:rPr>
+              <a:t>2. Remplir les détails : </a:t>
+            </a:r>
+            <a:r>
+              <a:rPr sz="1400">
+                <a:solidFill>
+                  <a:srgbClr val="1E293B"/>
+                </a:solidFill>
+              </a:rPr>
+              <a:t>Sélectionnez la Classe, le Professeur, la Matière et la Salle d'étude.</a:t>
             </a:r>
           </a:p>
           <a:p>
             <a:pPr/>
             <a:r>
-              <a:rPr b="1" sz="1800">
-                <a:solidFill>
-                  <a:srgbClr val="1E293B"/>
-                </a:solidFill>
-              </a:rPr>
-              <a:t>• Règle de Sécurité : </a:t>
-            </a:r>
-            <a:r>
-              <a:rPr sz="1600">
-                <a:solidFill>
-                  <a:srgbClr val="1E293B"/>
-                </a:solidFill>
-              </a:rPr>
-              <a:t>Les modifications après validation sont exclusivement réservées au Directeur et à l'Informaticien.</a:t>
+              <a:rPr b="1" sz="1500">
+                <a:solidFill>
+                  <a:srgbClr val="1E293B"/>
+                </a:solidFill>
+              </a:rPr>
+              <a:t>3. Choisir le créneau : </a:t>
+            </a:r>
+            <a:r>
+              <a:rPr sz="1400">
+                <a:solidFill>
+                  <a:srgbClr val="1E293B"/>
+                </a:solidFill>
+              </a:rPr>
+              <a:t>Choisissez le Jour de la semaine (ex: Lundi) et le Créneau horaire (ex: 08:00 - 10:00).</a:t>
             </a:r>
           </a:p>
           <a:p>
             <a:pPr/>
             <a:r>
-              <a:rPr b="1" sz="1800">
-                <a:solidFill>
-                  <a:srgbClr val="1E293B"/>
-                </a:solidFill>
-              </a:rPr>
-              <a:t>• Déverrouillage : </a:t>
-            </a:r>
-            <a:r>
-              <a:rPr sz="1600">
-                <a:solidFill>
-                  <a:srgbClr val="1E293B"/>
-                </a:solidFill>
-              </a:rPr>
-              <a:t>Le Directeur peut débloquer individuellement ou par lot les notes pour permettre un correctif.</a:t>
+              <a:rPr b="1" sz="1500">
+                <a:solidFill>
+                  <a:srgbClr val="1E293B"/>
+                </a:solidFill>
+              </a:rPr>
+              <a:t>4. Détection automatique : </a:t>
+            </a:r>
+            <a:r>
+              <a:rPr sz="1400">
+                <a:solidFill>
+                  <a:srgbClr val="1E293B"/>
+                </a:solidFill>
+              </a:rPr>
+              <a:t>Le système bloque instantanément la planification si le prof ou la salle est déjà occupé(e).</a:t>
+            </a:r>
+          </a:p>
+          <a:p>
+            <a:pPr/>
+            <a:r>
+              <a:rPr b="1" sz="1500">
+                <a:solidFill>
+                  <a:srgbClr val="1E293B"/>
+                </a:solidFill>
+              </a:rPr>
+              <a:t>5. Validation : </a:t>
+            </a:r>
+            <a:r>
+              <a:rPr sz="1400">
+                <a:solidFill>
+                  <a:srgbClr val="1E293B"/>
+                </a:solidFill>
+              </a:rPr>
+              <a:t>Cliquez sur 'Planifier ce cours' pour l'ajouter à la grille hebdomadaire.</a:t>
             </a:r>
           </a:p>
         </p:txBody>
@@ -3536,7 +3562,7 @@
           <a:lstStyle/>
           <a:p>
             <a:pPr>
-              <a:defRPr sz="2800" b="1">
+              <a:defRPr sz="2400" b="1">
                 <a:solidFill>
                   <a:srgbClr val="0B4998"/>
                 </a:solidFill>
@@ -3544,7 +3570,7 @@
               </a:defRPr>
             </a:pPr>
             <a:r>
-              <a:t>3. Procédure de Validation des Bulletins</a:t>
+              <a:t>Tutoriel 3 : Saisie des notes (Enseignants) &amp; Verrouillage</a:t>
             </a:r>
           </a:p>
         </p:txBody>
@@ -3557,8 +3583,8 @@
         </p:nvSpPr>
         <p:spPr>
           <a:xfrm>
-            <a:off x="457200" y="1371600"/>
-            <a:ext cx="11274552" cy="4572000"/>
+            <a:off x="457200" y="1097280"/>
+            <a:ext cx="11274552" cy="5303520"/>
           </a:xfrm>
           <a:prstGeom prst="rect">
             <a:avLst/>
@@ -3574,96 +3600,96 @@
           <a:p>
             <a:pPr/>
             <a:r>
-              <a:rPr b="1" sz="1800">
-                <a:solidFill>
-                  <a:srgbClr val="1E293B"/>
-                </a:solidFill>
-              </a:rPr>
-              <a:t>• Étape 1 : Saisie de notes </a:t>
-            </a:r>
-            <a:r>
-              <a:rPr sz="1600">
-                <a:solidFill>
-                  <a:srgbClr val="1E293B"/>
-                </a:solidFill>
-              </a:rPr>
-              <a:t>par les enseignants pour toutes les matières.</a:t>
+              <a:rPr b="1" sz="1500">
+                <a:solidFill>
+                  <a:srgbClr val="1E293B"/>
+                </a:solidFill>
+              </a:rPr>
+              <a:t>1. Connexion Professeur : </a:t>
+            </a:r>
+            <a:r>
+              <a:rPr sz="1400">
+                <a:solidFill>
+                  <a:srgbClr val="1E293B"/>
+                </a:solidFill>
+              </a:rPr>
+              <a:t>Connectez-vous au portail avec vos identifiants d'enseignant.</a:t>
             </a:r>
           </a:p>
           <a:p>
             <a:pPr/>
             <a:r>
-              <a:rPr b="1" sz="1800">
-                <a:solidFill>
-                  <a:srgbClr val="1E293B"/>
-                </a:solidFill>
-              </a:rPr>
-              <a:t>• Étape 2 : Consultation de la 'Natte' </a:t>
-            </a:r>
-            <a:r>
-              <a:rPr sz="1600">
-                <a:solidFill>
-                  <a:srgbClr val="1E293B"/>
-                </a:solidFill>
-              </a:rPr>
-              <a:t>par la direction pour vérification globale.</a:t>
+              <a:rPr b="1" sz="1500">
+                <a:solidFill>
+                  <a:srgbClr val="1E293B"/>
+                </a:solidFill>
+              </a:rPr>
+              <a:t>2. Sélectionner la classe : </a:t>
+            </a:r>
+            <a:r>
+              <a:rPr sz="1400">
+                <a:solidFill>
+                  <a:srgbClr val="1E293B"/>
+                </a:solidFill>
+              </a:rPr>
+              <a:t>Allez dans 'Espace Enseignant' &gt; 'Saisie des Moyennes', puis choisissez la Classe et la Matière.</a:t>
             </a:r>
           </a:p>
           <a:p>
             <a:pPr/>
             <a:r>
-              <a:rPr b="1" sz="1800">
-                <a:solidFill>
-                  <a:srgbClr val="1E293B"/>
-                </a:solidFill>
-              </a:rPr>
-              <a:t>• Étape 3 : Validation du Procès-Verbal (PV) </a:t>
-            </a:r>
-            <a:r>
-              <a:rPr sz="1600">
-                <a:solidFill>
-                  <a:srgbClr val="1E293B"/>
-                </a:solidFill>
-              </a:rPr>
-              <a:t>de la classe par le Directeur (onglet Évaluations).</a:t>
+              <a:rPr b="1" sz="1500">
+                <a:solidFill>
+                  <a:srgbClr val="1E293B"/>
+                </a:solidFill>
+              </a:rPr>
+              <a:t>3. Saisir les notes : </a:t>
+            </a:r>
+            <a:r>
+              <a:rPr sz="1400">
+                <a:solidFill>
+                  <a:srgbClr val="1E293B"/>
+                </a:solidFill>
+              </a:rPr>
+              <a:t>Entrez la note de chaque élève de la liste (valeur sur 20) et cliquez sur 'Enregistrer'.</a:t>
             </a:r>
           </a:p>
           <a:p>
             <a:pPr/>
             <a:r>
-              <a:rPr b="1" sz="1800">
-                <a:solidFill>
-                  <a:srgbClr val="1E293B"/>
-                </a:solidFill>
-              </a:rPr>
-              <a:t>• Étape 4 : Impression des Bulletins </a:t>
-            </a:r>
-            <a:r>
-              <a:rPr sz="1600">
-                <a:solidFill>
-                  <a:srgbClr val="1E293B"/>
-                </a:solidFill>
-              </a:rPr>
-              <a:t>devenue disponible uniquement après validation du PV de la classe.</a:t>
+              <a:rPr b="1" sz="1500">
+                <a:solidFill>
+                  <a:srgbClr val="1E293B"/>
+                </a:solidFill>
+              </a:rPr>
+              <a:t>4. Figer définitivement : </a:t>
+            </a:r>
+            <a:r>
+              <a:rPr sz="1400">
+                <a:solidFill>
+                  <a:srgbClr val="1E293B"/>
+                </a:solidFill>
+              </a:rPr>
+              <a:t>Cliquez sur le bouton vert '🔒 Valider &amp; Figer' pour verrouiller la saisie.</a:t>
             </a:r>
           </a:p>
           <a:p>
             <a:pPr/>
             <a:r>
-              <a:rPr b="1" sz="1800">
-                <a:solidFill>
-                  <a:srgbClr val="1E293B"/>
-                </a:solidFill>
-              </a:rPr>
-              <a:t>• Sécurité renforcée : </a:t>
-            </a:r>
-            <a:r>
-              <a:rPr sz="1600">
-                <a:solidFill>
-                  <a:srgbClr val="1E293B"/>
-                </a:solidFill>
-              </a:rPr>
-              <a:t>Aucun bulletin n'est éditable ou consultable si le PV de classe n'est pas validé au préalable.</a:t>
+              <a:rPr b="1" sz="1500">
+                <a:solidFill>
+                  <a:srgbClr val="1E293B"/>
+                </a:solidFill>
+              </a:rPr>
+              <a:t>5. Sécurité : </a:t>
+            </a:r>
+            <a:r>
+              <a:rPr sz="1400">
+                <a:solidFill>
+                  <a:srgbClr val="1E293B"/>
+                </a:solidFill>
+              </a:rPr>
+              <a:t>Une fois figée, la note affiche le badge '🔒 Figé' et le professeur ne peut plus la modifier.</a:t>
             </a:r>
           </a:p>
         </p:txBody>
@@ -3717,7 +3743,7 @@
           <a:lstStyle/>
           <a:p>
             <a:pPr>
-              <a:defRPr sz="2800" b="1">
+              <a:defRPr sz="2400" b="1">
                 <a:solidFill>
                   <a:srgbClr val="0B4998"/>
                 </a:solidFill>
@@ -3725,7 +3751,7 @@
               </a:defRPr>
             </a:pPr>
             <a:r>
-              <a:t>4. Emplois du Temps (EDT)</a:t>
+              <a:t>Tutoriel 4 : Déverrouiller une note (Direction)</a:t>
             </a:r>
           </a:p>
         </p:txBody>
@@ -3738,8 +3764,8 @@
         </p:nvSpPr>
         <p:spPr>
           <a:xfrm>
-            <a:off x="457200" y="1371600"/>
-            <a:ext cx="11274552" cy="4572000"/>
+            <a:off x="457200" y="1097280"/>
+            <a:ext cx="11274552" cy="5303520"/>
           </a:xfrm>
           <a:prstGeom prst="rect">
             <a:avLst/>
@@ -3755,77 +3781,77 @@
           <a:p>
             <a:pPr/>
             <a:r>
-              <a:rPr b="1" sz="1800">
-                <a:solidFill>
-                  <a:srgbClr val="1E293B"/>
-                </a:solidFill>
-              </a:rPr>
-              <a:t>• Planification intelligente : </a:t>
-            </a:r>
-            <a:r>
-              <a:rPr sz="1600">
-                <a:solidFill>
-                  <a:srgbClr val="1E293B"/>
-                </a:solidFill>
-              </a:rPr>
-              <a:t>Attribution des créneaux horaires, enseignants, salles et matières.</a:t>
+              <a:rPr b="1" sz="1500">
+                <a:solidFill>
+                  <a:srgbClr val="1E293B"/>
+                </a:solidFill>
+              </a:rPr>
+              <a:t>1. Accéder au portail prof : </a:t>
+            </a:r>
+            <a:r>
+              <a:rPr sz="1400">
+                <a:solidFill>
+                  <a:srgbClr val="1E293B"/>
+                </a:solidFill>
+              </a:rPr>
+              <a:t>Connectez-vous en tant que Directeur ou Super Admin et allez dans le portail enseignant.</a:t>
             </a:r>
           </a:p>
           <a:p>
             <a:pPr/>
             <a:r>
-              <a:rPr b="1" sz="1800">
-                <a:solidFill>
-                  <a:srgbClr val="1E293B"/>
-                </a:solidFill>
-              </a:rPr>
-              <a:t>• Détection des conflits : </a:t>
-            </a:r>
-            <a:r>
-              <a:rPr sz="1600">
-                <a:solidFill>
-                  <a:srgbClr val="1E293B"/>
-                </a:solidFill>
-              </a:rPr>
-              <a:t>Vérification instantanée en cas de double réservation d'enseignant, de salle ou d'horaire indisponible.</a:t>
+              <a:rPr b="1" sz="1500">
+                <a:solidFill>
+                  <a:srgbClr val="1E293B"/>
+                </a:solidFill>
+              </a:rPr>
+              <a:t>2. Trouver la note figée : </a:t>
+            </a:r>
+            <a:r>
+              <a:rPr sz="1400">
+                <a:solidFill>
+                  <a:srgbClr val="1E293B"/>
+                </a:solidFill>
+              </a:rPr>
+              <a:t>Sélectionnez la classe et la matière concernée dans le filtre du portail.</a:t>
             </a:r>
           </a:p>
           <a:p>
             <a:pPr/>
             <a:r>
-              <a:rPr b="1" sz="1800">
-                <a:solidFill>
-                  <a:srgbClr val="1E293B"/>
-                </a:solidFill>
-              </a:rPr>
-              <a:t>• Professeur Principal : </a:t>
-            </a:r>
-            <a:r>
-              <a:rPr sz="1600">
-                <a:solidFill>
-                  <a:srgbClr val="1E293B"/>
-                </a:solidFill>
-              </a:rPr>
-              <a:t>Chaque classe possède son enseignant principal attitré visible sur l'EDT et le bulletin.</a:t>
+              <a:rPr b="1" sz="1500">
+                <a:solidFill>
+                  <a:srgbClr val="1E293B"/>
+                </a:solidFill>
+              </a:rPr>
+              <a:t>3. Déverrouiller : </a:t>
+            </a:r>
+            <a:r>
+              <a:rPr sz="1400">
+                <a:solidFill>
+                  <a:srgbClr val="1E293B"/>
+                </a:solidFill>
+              </a:rPr>
+              <a:t>Cliquez sur le lien orange '🔓 Déverr.' à côté de la note verrouillée.</a:t>
             </a:r>
           </a:p>
           <a:p>
             <a:pPr/>
             <a:r>
-              <a:rPr b="1" sz="1800">
-                <a:solidFill>
-                  <a:srgbClr val="1E293B"/>
-                </a:solidFill>
-              </a:rPr>
-              <a:t>• Visualisation et Impression : </a:t>
-            </a:r>
-            <a:r>
-              <a:rPr sz="1600">
-                <a:solidFill>
-                  <a:srgbClr val="1E293B"/>
-                </a:solidFill>
-              </a:rPr>
-              <a:t>Grilles d'EDT claires filtrables par enseignant ou par classe prêtes pour l'impression.</a:t>
+              <a:rPr b="1" sz="1500">
+                <a:solidFill>
+                  <a:srgbClr val="1E293B"/>
+                </a:solidFill>
+              </a:rPr>
+              <a:t>4. Confirmation : </a:t>
+            </a:r>
+            <a:r>
+              <a:rPr sz="1400">
+                <a:solidFill>
+                  <a:srgbClr val="1E293B"/>
+                </a:solidFill>
+              </a:rPr>
+              <a:t>Confirmez l'alerte du navigateur. Le badge '🔒 Figé' disparaît et l'enseignant peut à nouveau corriger.</a:t>
             </a:r>
           </a:p>
         </p:txBody>
@@ -3879,7 +3905,7 @@
           <a:lstStyle/>
           <a:p>
             <a:pPr>
-              <a:defRPr sz="2800" b="1">
+              <a:defRPr sz="2400" b="1">
                 <a:solidFill>
                   <a:srgbClr val="0B4998"/>
                 </a:solidFill>
@@ -3887,7 +3913,7 @@
               </a:defRPr>
             </a:pPr>
             <a:r>
-              <a:t>5. Facturation &amp; Scolarité</a:t>
+              <a:t>Tutoriel 5 : Valider le Procès-Verbal (PV)</a:t>
             </a:r>
           </a:p>
         </p:txBody>
@@ -3900,8 +3926,8 @@
         </p:nvSpPr>
         <p:spPr>
           <a:xfrm>
-            <a:off x="457200" y="1371600"/>
-            <a:ext cx="11274552" cy="4572000"/>
+            <a:off x="457200" y="1097280"/>
+            <a:ext cx="11274552" cy="5303520"/>
           </a:xfrm>
           <a:prstGeom prst="rect">
             <a:avLst/>
@@ -3917,58 +3943,258 @@
           <a:p>
             <a:pPr/>
             <a:r>
-              <a:rPr b="1" sz="1800">
-                <a:solidFill>
-                  <a:srgbClr val="1E293B"/>
-                </a:solidFill>
-              </a:rPr>
-              <a:t>• Traçabilité financière : </a:t>
-            </a:r>
-            <a:r>
-              <a:rPr sz="1600">
-                <a:solidFill>
-                  <a:srgbClr val="1E293B"/>
-                </a:solidFill>
-              </a:rPr>
-              <a:t>Enregistrement des versements d'écolages par élève.</a:t>
+              <a:rPr b="1" sz="1500">
+                <a:solidFill>
+                  <a:srgbClr val="1E293B"/>
+                </a:solidFill>
+              </a:rPr>
+              <a:t>1. Accéder à l'onglet : </a:t>
+            </a:r>
+            <a:r>
+              <a:rPr sz="1400">
+                <a:solidFill>
+                  <a:srgbClr val="1E293B"/>
+                </a:solidFill>
+              </a:rPr>
+              <a:t>Allez sur 'Évaluations &amp; Examens' &gt; sous-onglet 'Procès-Verbaux &amp; Validation'.</a:t>
             </a:r>
           </a:p>
           <a:p>
             <a:pPr/>
             <a:r>
-              <a:rPr b="1" sz="1800">
-                <a:solidFill>
-                  <a:srgbClr val="1E293B"/>
-                </a:solidFill>
-              </a:rPr>
-              <a:t>• Reçus PDF officiels : </a:t>
-            </a:r>
-            <a:r>
-              <a:rPr sz="1600">
-                <a:solidFill>
-                  <a:srgbClr val="1E293B"/>
-                </a:solidFill>
-              </a:rPr>
-              <a:t>Génération automatique d'un reçu imprimable pour chaque transaction.</a:t>
+              <a:rPr b="1" sz="1500">
+                <a:solidFill>
+                  <a:srgbClr val="1E293B"/>
+                </a:solidFill>
+              </a:rPr>
+              <a:t>2. Vérifier la classe : </a:t>
+            </a:r>
+            <a:r>
+              <a:rPr sz="1400">
+                <a:solidFill>
+                  <a:srgbClr val="1E293B"/>
+                </a:solidFill>
+              </a:rPr>
+              <a:t>Sélectionnez la classe et examinez les moyennes affichées sur l'écran (Natte de vérification).</a:t>
             </a:r>
           </a:p>
           <a:p>
             <a:pPr/>
             <a:r>
-              <a:rPr b="1" sz="1800">
-                <a:solidFill>
-                  <a:srgbClr val="1E293B"/>
-                </a:solidFill>
-              </a:rPr>
-              <a:t>• Notification intégrée : </a:t>
-            </a:r>
-            <a:r>
-              <a:rPr sz="1600">
-                <a:solidFill>
-                  <a:srgbClr val="1E293B"/>
-                </a:solidFill>
-              </a:rPr>
-              <a:t>Bouton d'envoi rapide par WhatsApp ou SMS pour notifier instantanément les parents d'élèves.</a:t>
+              <a:rPr b="1" sz="1500">
+                <a:solidFill>
+                  <a:srgbClr val="1E293B"/>
+                </a:solidFill>
+              </a:rPr>
+              <a:t>3. Lancer la validation : </a:t>
+            </a:r>
+            <a:r>
+              <a:rPr sz="1400">
+                <a:solidFill>
+                  <a:srgbClr val="1E293B"/>
+                </a:solidFill>
+              </a:rPr>
+              <a:t>Cliquez sur 'Valider le PV pour cette Classe' pour verrouiller le trimestre.</a:t>
+            </a:r>
+          </a:p>
+          <a:p>
+            <a:pPr/>
+            <a:r>
+              <a:rPr b="1" sz="1500">
+                <a:solidFill>
+                  <a:srgbClr val="1E293B"/>
+                </a:solidFill>
+              </a:rPr>
+              <a:t>4. Effet immédiat : </a:t>
+            </a:r>
+            <a:r>
+              <a:rPr sz="1400">
+                <a:solidFill>
+                  <a:srgbClr val="1E293B"/>
+                </a:solidFill>
+              </a:rPr>
+              <a:t>Les bulletins scolaires de cette classe deviennent instantanément disponibles pour l'impression.</a:t>
+            </a:r>
+          </a:p>
+        </p:txBody>
+      </p:sp>
+    </p:spTree>
+  </p:cSld>
+  <p:clrMapOvr>
+    <a:masterClrMapping/>
+  </p:clrMapOvr>
+</p:sld>
+</file>
+
+<file path=ppt/slides/slide7.xml><?xml version="1.0" encoding="utf-8"?>
+<p:sld xmlns:a="http://schemas.openxmlformats.org/drawingml/2006/main" xmlns:p="http://schemas.openxmlformats.org/presentationml/2006/main" xmlns:r="http://schemas.openxmlformats.org/officeDocument/2006/relationships">
+  <p:cSld>
+    <p:bg>
+      <p:bgPr>
+        <a:solidFill>
+          <a:srgbClr val="F8FAFC"/>
+        </a:solidFill>
+        <a:effectLst/>
+      </p:bgPr>
+    </p:bg>
+    <p:spTree>
+      <p:nvGrpSpPr>
+        <p:cNvPr id="1" name=""/>
+        <p:cNvGrpSpPr/>
+        <p:nvPr/>
+      </p:nvGrpSpPr>
+      <p:grpSpPr/>
+      <p:sp>
+        <p:nvSpPr>
+          <p:cNvPr id="2" name="TextBox 1"/>
+          <p:cNvSpPr txBox="1"/>
+          <p:nvPr/>
+        </p:nvSpPr>
+        <p:spPr>
+          <a:xfrm>
+            <a:off x="457200" y="365760"/>
+            <a:ext cx="11274552" cy="731520"/>
+          </a:xfrm>
+          <a:prstGeom prst="rect">
+            <a:avLst/>
+          </a:prstGeom>
+          <a:noFill/>
+        </p:spPr>
+        <p:txBody>
+          <a:bodyPr wrap="square">
+            <a:spAutoFit/>
+          </a:bodyPr>
+          <a:lstStyle/>
+          <a:p>
+            <a:pPr>
+              <a:defRPr sz="2400" b="1">
+                <a:solidFill>
+                  <a:srgbClr val="0B4998"/>
+                </a:solidFill>
+                <a:latin typeface="Arial"/>
+              </a:defRPr>
+            </a:pPr>
+            <a:r>
+              <a:t>Tutoriel 6 : Enregistrer un paiement &amp; générer le reçu</a:t>
+            </a:r>
+          </a:p>
+        </p:txBody>
+      </p:sp>
+      <p:sp>
+        <p:nvSpPr>
+          <p:cNvPr id="3" name="TextBox 2"/>
+          <p:cNvSpPr txBox="1"/>
+          <p:nvPr/>
+        </p:nvSpPr>
+        <p:spPr>
+          <a:xfrm>
+            <a:off x="457200" y="1097280"/>
+            <a:ext cx="11274552" cy="5303520"/>
+          </a:xfrm>
+          <a:prstGeom prst="rect">
+            <a:avLst/>
+          </a:prstGeom>
+          <a:noFill/>
+        </p:spPr>
+        <p:txBody>
+          <a:bodyPr wrap="square">
+            <a:spAutoFit/>
+          </a:bodyPr>
+          <a:lstStyle/>
+          <a:p/>
+          <a:p>
+            <a:pPr/>
+            <a:r>
+              <a:rPr b="1" sz="1500">
+                <a:solidFill>
+                  <a:srgbClr val="1E293B"/>
+                </a:solidFill>
+              </a:rPr>
+              <a:t>1. Ouvrir l'onglet financier : </a:t>
+            </a:r>
+            <a:r>
+              <a:rPr sz="1400">
+                <a:solidFill>
+                  <a:srgbClr val="1E293B"/>
+                </a:solidFill>
+              </a:rPr>
+              <a:t>Sélectionnez l'onglet 'Finances &amp; Écolages'.</a:t>
+            </a:r>
+          </a:p>
+          <a:p>
+            <a:pPr/>
+            <a:r>
+              <a:rPr b="1" sz="1500">
+                <a:solidFill>
+                  <a:srgbClr val="1E293B"/>
+                </a:solidFill>
+              </a:rPr>
+              <a:t>2. Sélectionner l'élève : </a:t>
+            </a:r>
+            <a:r>
+              <a:rPr sz="1400">
+                <a:solidFill>
+                  <a:srgbClr val="1E293B"/>
+                </a:solidFill>
+              </a:rPr>
+              <a:t>Recherchez et sélectionnez l'élève dans la liste déroulante.</a:t>
+            </a:r>
+          </a:p>
+          <a:p>
+            <a:pPr/>
+            <a:r>
+              <a:rPr b="1" sz="1500">
+                <a:solidFill>
+                  <a:srgbClr val="1E293B"/>
+                </a:solidFill>
+              </a:rPr>
+              <a:t>3. Remplir le versement : </a:t>
+            </a:r>
+            <a:r>
+              <a:rPr sz="1400">
+                <a:solidFill>
+                  <a:srgbClr val="1E293B"/>
+                </a:solidFill>
+              </a:rPr>
+              <a:t>Entrez le Montant payé, le Motif du versement, et le Mode de règlement (Espèces, Chèque, etc.).</a:t>
+            </a:r>
+          </a:p>
+          <a:p>
+            <a:pPr/>
+            <a:r>
+              <a:rPr b="1" sz="1500">
+                <a:solidFill>
+                  <a:srgbClr val="1E293B"/>
+                </a:solidFill>
+              </a:rPr>
+              <a:t>4. Enregistrer : </a:t>
+            </a:r>
+            <a:r>
+              <a:rPr sz="1400">
+                <a:solidFill>
+                  <a:srgbClr val="1E293B"/>
+                </a:solidFill>
+              </a:rPr>
+              <a:t>Cliquez sur 'Enregistrer la transaction'. Le solde de l'élève se met à jour immédiatement.</a:t>
+            </a:r>
+          </a:p>
+          <a:p>
+            <a:pPr/>
+            <a:r>
+              <a:rPr b="1" sz="1500">
+                <a:solidFill>
+                  <a:srgbClr val="1E293B"/>
+                </a:solidFill>
+              </a:rPr>
+              <a:t>5. Télécharger/Envoyer : </a:t>
+            </a:r>
+            <a:r>
+              <a:rPr sz="1400">
+                <a:solidFill>
+                  <a:srgbClr val="1E293B"/>
+                </a:solidFill>
+              </a:rPr>
+              <a:t>Cliquez sur 'Générer Reçu PDF' pour l'imprimer, ou utilisez le bouton WhatsApp pour envoyer la notification.</a:t>
             </a:r>
           </a:p>
         </p:txBody>

</xml_diff>